<commit_message>
docs: align deck running headers with new title
Update the running header on content slides 2-10 from "Blood Cancer
Identification — Hybrid Ensemble + MC Dropout" to "Uncertainty-Aware
Hybrid CNN Ensemble + MC Dropout". Header text only; slide content,
numbers, figures and the cover are unchanged.

Co-Authored-By: Claude Opus 4.8 <noreply@anthropic.com>
</commit_message>
<xml_diff>
--- a/docs/presentation.pptx
+++ b/docs/presentation.pptx
@@ -4403,7 +4403,7 @@
                 </a:solidFill>
                 <a:latin typeface="Calibri"/>
               </a:rPr>
-              <a:t>Blood Cancer Identification · Hybrid Ensemble + MC Dropout</a:t>
+              <a:t>Uncertainty-Aware Hybrid CNN Ensemble + MC Dropout</a:t>
             </a:r>
           </a:p>
         </p:txBody>
@@ -5028,7 +5028,7 @@
                 </a:solidFill>
                 <a:latin typeface="Calibri"/>
               </a:rPr>
-              <a:t>Blood Cancer Identification · Hybrid Ensemble + MC Dropout</a:t>
+              <a:t>Uncertainty-Aware Hybrid CNN Ensemble + MC Dropout</a:t>
             </a:r>
           </a:p>
         </p:txBody>
@@ -5452,7 +5452,7 @@
                 </a:solidFill>
                 <a:latin typeface="Calibri"/>
               </a:rPr>
-              <a:t>Blood Cancer Identification · Hybrid Ensemble + MC Dropout</a:t>
+              <a:t>Uncertainty-Aware Hybrid CNN Ensemble + MC Dropout</a:t>
             </a:r>
           </a:p>
         </p:txBody>
@@ -5895,7 +5895,7 @@
                 </a:solidFill>
                 <a:latin typeface="Calibri"/>
               </a:rPr>
-              <a:t>Blood Cancer Identification · Hybrid Ensemble + MC Dropout</a:t>
+              <a:t>Uncertainty-Aware Hybrid CNN Ensemble + MC Dropout</a:t>
             </a:r>
           </a:p>
         </p:txBody>
@@ -6811,7 +6811,7 @@
                 </a:solidFill>
                 <a:latin typeface="Calibri"/>
               </a:rPr>
-              <a:t>Blood Cancer Identification · Hybrid Ensemble + MC Dropout</a:t>
+              <a:t>Uncertainty-Aware Hybrid CNN Ensemble + MC Dropout</a:t>
             </a:r>
           </a:p>
         </p:txBody>
@@ -7354,7 +7354,7 @@
                 </a:solidFill>
                 <a:latin typeface="Calibri"/>
               </a:rPr>
-              <a:t>Blood Cancer Identification · Hybrid Ensemble + MC Dropout</a:t>
+              <a:t>Uncertainty-Aware Hybrid CNN Ensemble + MC Dropout</a:t>
             </a:r>
           </a:p>
         </p:txBody>
@@ -8022,7 +8022,7 @@
                 </a:solidFill>
                 <a:latin typeface="Calibri"/>
               </a:rPr>
-              <a:t>Blood Cancer Identification · Hybrid Ensemble + MC Dropout</a:t>
+              <a:t>Uncertainty-Aware Hybrid CNN Ensemble + MC Dropout</a:t>
             </a:r>
           </a:p>
         </p:txBody>
@@ -9158,7 +9158,7 @@
                 </a:solidFill>
                 <a:latin typeface="Calibri"/>
               </a:rPr>
-              <a:t>Blood Cancer Identification · Hybrid Ensemble + MC Dropout</a:t>
+              <a:t>Uncertainty-Aware Hybrid CNN Ensemble + MC Dropout</a:t>
             </a:r>
           </a:p>
         </p:txBody>
@@ -9714,7 +9714,7 @@
                 </a:solidFill>
                 <a:latin typeface="Calibri"/>
               </a:rPr>
-              <a:t>Blood Cancer Identification · Hybrid Ensemble + MC Dropout</a:t>
+              <a:t>Uncertainty-Aware Hybrid CNN Ensemble + MC Dropout</a:t>
             </a:r>
           </a:p>
         </p:txBody>

</xml_diff>